<commit_message>
fix: ground agentic app coverage in real frameworks
Replace abstract planner/tool-caller/summarizer architecture with
framework-grounded guidance. Show config-only model swap across
Foundry Agent Service, Microsoft Agent Framework, LangChain, and
Semantic Kernel. Focus evaluation on real migration risks:
tool-calling behavior, instruction adherence, structured outputs.

PPTX slide 8 rewritten as 'Config-Only Swap + What to Evaluate'.
Docs Agent Workflow section now includes framework code snippets
and .env-driven config examples.

Co-authored-by: Copilot <223556219+Copilot@users.noreply.github.com>
</commit_message>
<xml_diff>
--- a/docs/azure-openai-model-migration-approach.pptx
+++ b/docs/azure-openai-model-migration-approach.pptx
@@ -9742,7 +9742,7 @@
                         </a:defRPr>
                       </a:pPr>
                       <a:r>
-                        <a:t>Same dual-layer methodology.</a:t>
+                        <a:t>Same config-only swap applies.</a:t>
                       </a:r>
                     </a:p>
                     <a:p>
@@ -9755,7 +9755,7 @@
                         </a:defRPr>
                       </a:pPr>
                       <a:r>
-                        <a:t>Planner, tool-caller, summarizer</a:t>
+                        <a:t>Model is one .env/config value in</a:t>
                       </a:r>
                     </a:p>
                     <a:p>
@@ -9768,7 +9768,7 @@
                         </a:defRPr>
                       </a:pPr>
                       <a:r>
-                        <a:t>each tested at task level.</a:t>
+                        <a:t>every framework. Same eval methodology.</a:t>
                       </a:r>
                     </a:p>
                   </a:txBody>
@@ -9792,7 +9792,7 @@
                         </a:defRPr>
                       </a:pPr>
                       <a:r>
-                        <a:t>Agentic evaluation slide +</a:t>
+                        <a:t>Framework config examples +</a:t>
                       </a:r>
                     </a:p>
                     <a:p>
@@ -12642,7 +12642,7 @@
               </a:defRPr>
             </a:pPr>
             <a:r>
-              <a:t>Planner</a:t>
+              <a:t>Reasoning</a:t>
             </a:r>
             <a:br/>
             <a:r>
@@ -12761,11 +12761,11 @@
               </a:defRPr>
             </a:pPr>
             <a:r>
-              <a:t>Tool Caller</a:t>
+              <a:t>Tool Calling</a:t>
             </a:r>
             <a:br/>
             <a:r>
-              <a:t>(LLM + APIs)</a:t>
+              <a:t>(LLM → APIs)</a:t>
             </a:r>
           </a:p>
         </p:txBody>
@@ -12880,7 +12880,7 @@
               </a:defRPr>
             </a:pPr>
             <a:r>
-              <a:t>Execute</a:t>
+              <a:t>Execution</a:t>
             </a:r>
             <a:br/>
             <a:r>
@@ -12999,7 +12999,7 @@
               </a:defRPr>
             </a:pPr>
             <a:r>
-              <a:t>Summarize</a:t>
+              <a:t>Response</a:t>
             </a:r>
             <a:br/>
             <a:r>
@@ -13016,8 +13016,8 @@
         </p:nvSpPr>
         <p:spPr>
           <a:xfrm>
-            <a:off x="731520" y="3566160"/>
-            <a:ext cx="10058400" cy="365760"/>
+            <a:off x="457200" y="3383280"/>
+            <a:ext cx="10972800" cy="274320"/>
           </a:xfrm>
           <a:prstGeom prst="rect">
             <a:avLst/>
@@ -13031,15 +13031,15 @@
           <a:lstStyle/>
           <a:p>
             <a:pPr algn="l">
-              <a:defRPr sz="1700" b="1">
-                <a:solidFill>
-                  <a:srgbClr val="D13438"/>
-                </a:solidFill>
-                <a:latin typeface="Segoe UI"/>
-              </a:defRPr>
-            </a:pPr>
-            <a:r>
-              <a:t>The emergent regression problem:</a:t>
+              <a:defRPr sz="1200" b="0">
+                <a:solidFill>
+                  <a:srgbClr val="606060"/>
+                </a:solidFill>
+                <a:latin typeface="Segoe UI"/>
+              </a:defRPr>
+            </a:pPr>
+            <a:r>
+              <a:t>Built with: Foundry Agent Service  •  Microsoft Agent Framework  •  Semantic Kernel  •  LangChain/LangGraph  •  OpenAI SDK</a:t>
             </a:r>
           </a:p>
         </p:txBody>
@@ -13052,8 +13052,8 @@
         </p:nvSpPr>
         <p:spPr>
           <a:xfrm>
-            <a:off x="731520" y="3931920"/>
-            <a:ext cx="10515600" cy="914400"/>
+            <a:off x="731520" y="3566160"/>
+            <a:ext cx="10058400" cy="365760"/>
           </a:xfrm>
           <a:prstGeom prst="rect">
             <a:avLst/>
@@ -13067,6 +13067,42 @@
           <a:lstStyle/>
           <a:p>
             <a:pPr algn="l">
+              <a:defRPr sz="1700" b="1">
+                <a:solidFill>
+                  <a:srgbClr val="D13438"/>
+                </a:solidFill>
+                <a:latin typeface="Segoe UI"/>
+              </a:defRPr>
+            </a:pPr>
+            <a:r>
+              <a:t>The emergent regression problem:</a:t>
+            </a:r>
+          </a:p>
+        </p:txBody>
+      </p:sp>
+      <p:sp>
+        <p:nvSpPr>
+          <p:cNvPr id="31" name="TextBox 30"/>
+          <p:cNvSpPr txBox="1"/>
+          <p:nvPr/>
+        </p:nvSpPr>
+        <p:spPr>
+          <a:xfrm>
+            <a:off x="731520" y="3931920"/>
+            <a:ext cx="10515600" cy="914400"/>
+          </a:xfrm>
+          <a:prstGeom prst="rect">
+            <a:avLst/>
+          </a:prstGeom>
+          <a:noFill/>
+        </p:spPr>
+        <p:txBody>
+          <a:bodyPr wrap="square">
+            <a:spAutoFit/>
+          </a:bodyPr>
+          <a:lstStyle/>
+          <a:p>
+            <a:pPr algn="l">
               <a:defRPr sz="1400" b="0">
                 <a:solidFill>
                   <a:srgbClr val="606060"/>
@@ -13075,14 +13111,14 @@
               </a:defRPr>
             </a:pPr>
             <a:r>
-              <a:t>Upgrading ONE step can break the whole chain. In RAG: better embeddings surface different documents → generation quality drops. In agentic apps: a new planner model chooses different tool sequences → downstream calls fail or produce different results. The regression is EMERGENT — it only appears when steps interact.</a:t>
-            </a:r>
-          </a:p>
-        </p:txBody>
-      </p:sp>
-      <p:sp>
-        <p:nvSpPr>
-          <p:cNvPr id="31" name="Rectangle 30"/>
+              <a:t>Upgrading ONE model can break the whole chain. In RAG: better embeddings surface different documents → generation quality drops. In agentic apps: a new model selects different tools or extracts different parameters → downstream calls fail or produce unexpected results. The regression is EMERGENT — it only appears when steps interact.</a:t>
+            </a:r>
+          </a:p>
+        </p:txBody>
+      </p:sp>
+      <p:sp>
+        <p:nvSpPr>
+          <p:cNvPr id="32" name="Rectangle 31"/>
           <p:cNvSpPr/>
           <p:nvPr/>
         </p:nvSpPr>
@@ -13125,7 +13161,7 @@
       </p:sp>
       <p:sp>
         <p:nvSpPr>
-          <p:cNvPr id="32" name="TextBox 31"/>
+          <p:cNvPr id="33" name="TextBox 32"/>
           <p:cNvSpPr txBox="1"/>
           <p:nvPr/>
         </p:nvSpPr>
@@ -13161,7 +13197,7 @@
       </p:sp>
       <p:sp>
         <p:nvSpPr>
-          <p:cNvPr id="33" name="TextBox 32"/>
+          <p:cNvPr id="34" name="TextBox 33"/>
           <p:cNvSpPr txBox="1"/>
           <p:nvPr/>
         </p:nvSpPr>
@@ -13241,7 +13277,7 @@
       </p:sp>
       <p:sp>
         <p:nvSpPr>
-          <p:cNvPr id="34" name="Rectangle 33"/>
+          <p:cNvPr id="35" name="Rectangle 34"/>
           <p:cNvSpPr/>
           <p:nvPr/>
         </p:nvSpPr>
@@ -13284,7 +13320,7 @@
       </p:sp>
       <p:sp>
         <p:nvSpPr>
-          <p:cNvPr id="35" name="TextBox 34"/>
+          <p:cNvPr id="36" name="TextBox 35"/>
           <p:cNvSpPr txBox="1"/>
           <p:nvPr/>
         </p:nvSpPr>
@@ -13320,7 +13356,7 @@
       </p:sp>
       <p:sp>
         <p:nvSpPr>
-          <p:cNvPr id="36" name="TextBox 35"/>
+          <p:cNvPr id="37" name="TextBox 36"/>
           <p:cNvSpPr txBox="1"/>
           <p:nvPr/>
         </p:nvSpPr>
@@ -16633,7 +16669,7 @@
               </a:defRPr>
             </a:pPr>
             <a:r>
-              <a:t>Evaluating Agentic Applications</a:t>
+              <a:t>Agentic Apps: Config-Only Swap + What to Evaluate</a:t>
             </a:r>
           </a:p>
         </p:txBody>
@@ -16647,7 +16683,7 @@
         <p:spPr>
           <a:xfrm>
             <a:off x="457200" y="1097280"/>
-            <a:ext cx="10972800" cy="365760"/>
+            <a:ext cx="5303520" cy="365760"/>
           </a:xfrm>
           <a:prstGeom prst="rect">
             <a:avLst/>
@@ -16661,7 +16697,7 @@
           <a:lstStyle/>
           <a:p>
             <a:pPr algn="l">
-              <a:defRPr sz="1600" b="1">
+              <a:defRPr sz="1500" b="1">
                 <a:solidFill>
                   <a:srgbClr val="002B5C"/>
                 </a:solidFill>
@@ -16669,7 +16705,7 @@
               </a:defRPr>
             </a:pPr>
             <a:r>
-              <a:t>Agents add planning and tool calling — the same dual-layer methodology applies, with agentic-specific metrics:</a:t>
+              <a:t>Model swap in every framework = change one config value:</a:t>
             </a:r>
           </a:p>
         </p:txBody>
@@ -16682,8 +16718,383 @@
         </p:nvSpPr>
         <p:spPr>
           <a:xfrm>
-            <a:off x="365760" y="1645920"/>
-            <a:ext cx="3474720" cy="2377440"/>
+            <a:off x="457200" y="1554480"/>
+            <a:ext cx="5303520" cy="3200400"/>
+          </a:xfrm>
+          <a:prstGeom prst="rect">
+            <a:avLst/>
+          </a:prstGeom>
+          <a:solidFill>
+            <a:srgbClr val="F2F2F2"/>
+          </a:solidFill>
+          <a:ln>
+            <a:noFill/>
+          </a:ln>
+        </p:spPr>
+        <p:style>
+          <a:lnRef idx="1">
+            <a:schemeClr val="accent1"/>
+          </a:lnRef>
+          <a:fillRef idx="3">
+            <a:schemeClr val="accent1"/>
+          </a:fillRef>
+          <a:effectRef idx="2">
+            <a:schemeClr val="accent1"/>
+          </a:effectRef>
+          <a:fontRef idx="minor">
+            <a:schemeClr val="lt1"/>
+          </a:fontRef>
+        </p:style>
+        <p:txBody>
+          <a:bodyPr rtlCol="0" anchor="ctr"/>
+          <a:lstStyle/>
+          <a:p>
+            <a:pPr algn="ctr"/>
+          </a:p>
+        </p:txBody>
+      </p:sp>
+      <p:sp>
+        <p:nvSpPr>
+          <p:cNvPr id="6" name="TextBox 5"/>
+          <p:cNvSpPr txBox="1"/>
+          <p:nvPr/>
+        </p:nvSpPr>
+        <p:spPr>
+          <a:xfrm>
+            <a:off x="640080" y="1645920"/>
+            <a:ext cx="4937760" cy="274320"/>
+          </a:xfrm>
+          <a:prstGeom prst="rect">
+            <a:avLst/>
+          </a:prstGeom>
+          <a:noFill/>
+        </p:spPr>
+        <p:txBody>
+          <a:bodyPr wrap="square">
+            <a:spAutoFit/>
+          </a:bodyPr>
+          <a:lstStyle/>
+          <a:p>
+            <a:pPr algn="l">
+              <a:defRPr sz="1400" b="1">
+                <a:solidFill>
+                  <a:srgbClr val="107C10"/>
+                </a:solidFill>
+                <a:latin typeface="Segoe UI"/>
+              </a:defRPr>
+            </a:pPr>
+            <a:r>
+              <a:t>Foundry Agent Service</a:t>
+            </a:r>
+          </a:p>
+        </p:txBody>
+      </p:sp>
+      <p:sp>
+        <p:nvSpPr>
+          <p:cNvPr id="7" name="TextBox 6"/>
+          <p:cNvSpPr txBox="1"/>
+          <p:nvPr/>
+        </p:nvSpPr>
+        <p:spPr>
+          <a:xfrm>
+            <a:off x="640080" y="1920240"/>
+            <a:ext cx="4937760" cy="457200"/>
+          </a:xfrm>
+          <a:prstGeom prst="rect">
+            <a:avLst/>
+          </a:prstGeom>
+          <a:noFill/>
+        </p:spPr>
+        <p:txBody>
+          <a:bodyPr wrap="square">
+            <a:spAutoFit/>
+          </a:bodyPr>
+          <a:lstStyle/>
+          <a:p>
+            <a:pPr algn="l">
+              <a:defRPr sz="1200" b="0">
+                <a:solidFill>
+                  <a:srgbClr val="606060"/>
+                </a:solidFill>
+                <a:latin typeface="Consolas"/>
+              </a:defRPr>
+            </a:pPr>
+            <a:r>
+              <a:t>PromptAgentDefinition(model="gpt-4o")  →  model="gpt-4.1"</a:t>
+            </a:r>
+          </a:p>
+        </p:txBody>
+      </p:sp>
+      <p:sp>
+        <p:nvSpPr>
+          <p:cNvPr id="8" name="TextBox 7"/>
+          <p:cNvSpPr txBox="1"/>
+          <p:nvPr/>
+        </p:nvSpPr>
+        <p:spPr>
+          <a:xfrm>
+            <a:off x="640080" y="2377440"/>
+            <a:ext cx="4937760" cy="274320"/>
+          </a:xfrm>
+          <a:prstGeom prst="rect">
+            <a:avLst/>
+          </a:prstGeom>
+          <a:noFill/>
+        </p:spPr>
+        <p:txBody>
+          <a:bodyPr wrap="square">
+            <a:spAutoFit/>
+          </a:bodyPr>
+          <a:lstStyle/>
+          <a:p>
+            <a:pPr algn="l">
+              <a:defRPr sz="1400" b="1">
+                <a:solidFill>
+                  <a:srgbClr val="107C10"/>
+                </a:solidFill>
+                <a:latin typeface="Segoe UI"/>
+              </a:defRPr>
+            </a:pPr>
+            <a:r>
+              <a:t>Microsoft Agent Framework (Python)</a:t>
+            </a:r>
+          </a:p>
+        </p:txBody>
+      </p:sp>
+      <p:sp>
+        <p:nvSpPr>
+          <p:cNvPr id="9" name="TextBox 8"/>
+          <p:cNvSpPr txBox="1"/>
+          <p:nvPr/>
+        </p:nvSpPr>
+        <p:spPr>
+          <a:xfrm>
+            <a:off x="640080" y="2651760"/>
+            <a:ext cx="4937760" cy="457200"/>
+          </a:xfrm>
+          <a:prstGeom prst="rect">
+            <a:avLst/>
+          </a:prstGeom>
+          <a:noFill/>
+        </p:spPr>
+        <p:txBody>
+          <a:bodyPr wrap="square">
+            <a:spAutoFit/>
+          </a:bodyPr>
+          <a:lstStyle/>
+          <a:p>
+            <a:pPr algn="l">
+              <a:defRPr sz="1200" b="0">
+                <a:solidFill>
+                  <a:srgbClr val="606060"/>
+                </a:solidFill>
+                <a:latin typeface="Consolas"/>
+              </a:defRPr>
+            </a:pPr>
+            <a:r>
+              <a:t>client.as_agent(deployment_name=os.environ["MODEL"])</a:t>
+            </a:r>
+            <a:br/>
+            <a:r>
+              <a:t># .env: MODEL=gpt-4o  →  MODEL=gpt-4.1</a:t>
+            </a:r>
+          </a:p>
+        </p:txBody>
+      </p:sp>
+      <p:sp>
+        <p:nvSpPr>
+          <p:cNvPr id="10" name="TextBox 9"/>
+          <p:cNvSpPr txBox="1"/>
+          <p:nvPr/>
+        </p:nvSpPr>
+        <p:spPr>
+          <a:xfrm>
+            <a:off x="640080" y="3200400"/>
+            <a:ext cx="4937760" cy="274320"/>
+          </a:xfrm>
+          <a:prstGeom prst="rect">
+            <a:avLst/>
+          </a:prstGeom>
+          <a:noFill/>
+        </p:spPr>
+        <p:txBody>
+          <a:bodyPr wrap="square">
+            <a:spAutoFit/>
+          </a:bodyPr>
+          <a:lstStyle/>
+          <a:p>
+            <a:pPr algn="l">
+              <a:defRPr sz="1400" b="1">
+                <a:solidFill>
+                  <a:srgbClr val="107C10"/>
+                </a:solidFill>
+                <a:latin typeface="Segoe UI"/>
+              </a:defRPr>
+            </a:pPr>
+            <a:r>
+              <a:t>LangChain / LangGraph</a:t>
+            </a:r>
+          </a:p>
+        </p:txBody>
+      </p:sp>
+      <p:sp>
+        <p:nvSpPr>
+          <p:cNvPr id="11" name="TextBox 10"/>
+          <p:cNvSpPr txBox="1"/>
+          <p:nvPr/>
+        </p:nvSpPr>
+        <p:spPr>
+          <a:xfrm>
+            <a:off x="640080" y="3474720"/>
+            <a:ext cx="4937760" cy="457200"/>
+          </a:xfrm>
+          <a:prstGeom prst="rect">
+            <a:avLst/>
+          </a:prstGeom>
+          <a:noFill/>
+        </p:spPr>
+        <p:txBody>
+          <a:bodyPr wrap="square">
+            <a:spAutoFit/>
+          </a:bodyPr>
+          <a:lstStyle/>
+          <a:p>
+            <a:pPr algn="l">
+              <a:defRPr sz="1200" b="0">
+                <a:solidFill>
+                  <a:srgbClr val="606060"/>
+                </a:solidFill>
+                <a:latin typeface="Consolas"/>
+              </a:defRPr>
+            </a:pPr>
+            <a:r>
+              <a:t>ChatOpenAI(model=os.environ["MODEL"])</a:t>
+            </a:r>
+            <a:br/>
+            <a:r>
+              <a:t># .env: MODEL=gpt-4o  →  MODEL=gpt-4.1</a:t>
+            </a:r>
+          </a:p>
+        </p:txBody>
+      </p:sp>
+      <p:sp>
+        <p:nvSpPr>
+          <p:cNvPr id="12" name="TextBox 11"/>
+          <p:cNvSpPr txBox="1"/>
+          <p:nvPr/>
+        </p:nvSpPr>
+        <p:spPr>
+          <a:xfrm>
+            <a:off x="640080" y="4023360"/>
+            <a:ext cx="4937760" cy="274320"/>
+          </a:xfrm>
+          <a:prstGeom prst="rect">
+            <a:avLst/>
+          </a:prstGeom>
+          <a:noFill/>
+        </p:spPr>
+        <p:txBody>
+          <a:bodyPr wrap="square">
+            <a:spAutoFit/>
+          </a:bodyPr>
+          <a:lstStyle/>
+          <a:p>
+            <a:pPr algn="l">
+              <a:defRPr sz="1400" b="1">
+                <a:solidFill>
+                  <a:srgbClr val="107C10"/>
+                </a:solidFill>
+                <a:latin typeface="Segoe UI"/>
+              </a:defRPr>
+            </a:pPr>
+            <a:r>
+              <a:t>Semantic Kernel</a:t>
+            </a:r>
+          </a:p>
+        </p:txBody>
+      </p:sp>
+      <p:sp>
+        <p:nvSpPr>
+          <p:cNvPr id="13" name="TextBox 12"/>
+          <p:cNvSpPr txBox="1"/>
+          <p:nvPr/>
+        </p:nvSpPr>
+        <p:spPr>
+          <a:xfrm>
+            <a:off x="640080" y="4297680"/>
+            <a:ext cx="4937760" cy="365760"/>
+          </a:xfrm>
+          <a:prstGeom prst="rect">
+            <a:avLst/>
+          </a:prstGeom>
+          <a:noFill/>
+        </p:spPr>
+        <p:txBody>
+          <a:bodyPr wrap="square">
+            <a:spAutoFit/>
+          </a:bodyPr>
+          <a:lstStyle/>
+          <a:p>
+            <a:pPr algn="l">
+              <a:defRPr sz="1200" b="0">
+                <a:solidFill>
+                  <a:srgbClr val="606060"/>
+                </a:solidFill>
+                <a:latin typeface="Consolas"/>
+              </a:defRPr>
+            </a:pPr>
+            <a:r>
+              <a:t>kernel.add_service(deployment_name=os.environ["MODEL"])</a:t>
+            </a:r>
+          </a:p>
+        </p:txBody>
+      </p:sp>
+      <p:sp>
+        <p:nvSpPr>
+          <p:cNvPr id="14" name="TextBox 13"/>
+          <p:cNvSpPr txBox="1"/>
+          <p:nvPr/>
+        </p:nvSpPr>
+        <p:spPr>
+          <a:xfrm>
+            <a:off x="6217920" y="1097280"/>
+            <a:ext cx="5303520" cy="365760"/>
+          </a:xfrm>
+          <a:prstGeom prst="rect">
+            <a:avLst/>
+          </a:prstGeom>
+          <a:noFill/>
+        </p:spPr>
+        <p:txBody>
+          <a:bodyPr wrap="square">
+            <a:spAutoFit/>
+          </a:bodyPr>
+          <a:lstStyle/>
+          <a:p>
+            <a:pPr algn="l">
+              <a:defRPr sz="1500" b="1">
+                <a:solidFill>
+                  <a:srgbClr val="002B5C"/>
+                </a:solidFill>
+                <a:latin typeface="Segoe UI"/>
+              </a:defRPr>
+            </a:pPr>
+            <a:r>
+              <a:t>What to evaluate after swapping the model:</a:t>
+            </a:r>
+          </a:p>
+        </p:txBody>
+      </p:sp>
+      <p:sp>
+        <p:nvSpPr>
+          <p:cNvPr id="15" name="Rectangle 14"/>
+          <p:cNvSpPr/>
+          <p:nvPr/>
+        </p:nvSpPr>
+        <p:spPr>
+          <a:xfrm>
+            <a:off x="6217920" y="1554480"/>
+            <a:ext cx="5303520" cy="1097280"/>
           </a:xfrm>
           <a:prstGeom prst="rect">
             <a:avLst/>
@@ -16719,20 +17130,20 @@
       </p:sp>
       <p:sp>
         <p:nvSpPr>
-          <p:cNvPr id="6" name="Rectangle 5"/>
+          <p:cNvPr id="16" name="Rectangle 15"/>
           <p:cNvSpPr/>
           <p:nvPr/>
         </p:nvSpPr>
         <p:spPr>
           <a:xfrm>
-            <a:off x="365760" y="1645920"/>
-            <a:ext cx="3474720" cy="54864"/>
+            <a:off x="6217920" y="1554480"/>
+            <a:ext cx="5303520" cy="54864"/>
           </a:xfrm>
           <a:prstGeom prst="rect">
             <a:avLst/>
           </a:prstGeom>
           <a:solidFill>
-            <a:srgbClr val="107C10"/>
+            <a:srgbClr val="FF8C00"/>
           </a:solidFill>
           <a:ln>
             <a:noFill/>
@@ -16762,20 +17173,20 @@
       </p:sp>
       <p:sp>
         <p:nvSpPr>
-          <p:cNvPr id="7" name="Oval 6"/>
+          <p:cNvPr id="17" name="Oval 16"/>
           <p:cNvSpPr/>
           <p:nvPr/>
         </p:nvSpPr>
         <p:spPr>
           <a:xfrm>
-            <a:off x="640080" y="1920240"/>
+            <a:off x="6492240" y="1828800"/>
             <a:ext cx="640080" cy="640080"/>
           </a:xfrm>
           <a:prstGeom prst="ellipse">
             <a:avLst/>
           </a:prstGeom>
           <a:solidFill>
-            <a:srgbClr val="107C10"/>
+            <a:srgbClr val="FF8C00"/>
           </a:solidFill>
           <a:ln>
             <a:noFill/>
@@ -16807,21 +17218,21 @@
               </a:defRPr>
             </a:pPr>
             <a:r>
-              <a:t>🧠</a:t>
-            </a:r>
-          </a:p>
-        </p:txBody>
-      </p:sp>
-      <p:sp>
-        <p:nvSpPr>
-          <p:cNvPr id="8" name="TextBox 7"/>
+              <a:t>🔧</a:t>
+            </a:r>
+          </a:p>
+        </p:txBody>
+      </p:sp>
+      <p:sp>
+        <p:nvSpPr>
+          <p:cNvPr id="18" name="TextBox 17"/>
           <p:cNvSpPr txBox="1"/>
           <p:nvPr/>
         </p:nvSpPr>
         <p:spPr>
           <a:xfrm>
-            <a:off x="548640" y="2697480"/>
-            <a:ext cx="3108960" cy="365760"/>
+            <a:off x="6400800" y="2606040"/>
+            <a:ext cx="4937760" cy="365760"/>
           </a:xfrm>
           <a:prstGeom prst="rect">
             <a:avLst/>
@@ -16843,21 +17254,21 @@
               </a:defRPr>
             </a:pPr>
             <a:r>
-              <a:t>Planner (highest risk)</a:t>
-            </a:r>
-          </a:p>
-        </p:txBody>
-      </p:sp>
-      <p:sp>
-        <p:nvSpPr>
-          <p:cNvPr id="9" name="TextBox 8"/>
+              <a:t>Tool-Calling Behavior</a:t>
+            </a:r>
+          </a:p>
+        </p:txBody>
+      </p:sp>
+      <p:sp>
+        <p:nvSpPr>
+          <p:cNvPr id="19" name="TextBox 18"/>
           <p:cNvSpPr txBox="1"/>
           <p:nvPr/>
         </p:nvSpPr>
         <p:spPr>
           <a:xfrm>
-            <a:off x="548640" y="3063240"/>
-            <a:ext cx="3108960" cy="731520"/>
+            <a:off x="6400800" y="2971800"/>
+            <a:ext cx="4937760" cy="-548640"/>
           </a:xfrm>
           <a:prstGeom prst="rect">
             <a:avLst/>
@@ -16879,42 +17290,29 @@
               </a:defRPr>
             </a:pPr>
             <a:r>
-              <a:t>Does it pick the right tools in</a:t>
+              <a:t>Does the new model still select the right tools</a:t>
             </a:r>
             <a:br/>
             <a:r>
-              <a:t>the right order?</a:t>
+              <a:t>with the right parameters? Different models</a:t>
             </a:r>
             <a:br/>
-            <a:br/>
-            <a:r>
-              <a:t>• Plan correctness vs golden plans</a:t>
-            </a:r>
-            <a:br/>
-            <a:r>
-              <a:t>• Tool-selection accuracy</a:t>
-            </a:r>
-            <a:br/>
-            <a:r>
-              <a:t>• Step-ordering stability</a:t>
-            </a:r>
-            <a:br/>
-            <a:r>
-              <a:t>• Migrate FIRST — drives everything</a:t>
-            </a:r>
-          </a:p>
-        </p:txBody>
-      </p:sp>
-      <p:sp>
-        <p:nvSpPr>
-          <p:cNvPr id="10" name="Rectangle 9"/>
+            <a:r>
+              <a:t>may prefer different tools for the same task.</a:t>
+            </a:r>
+          </a:p>
+        </p:txBody>
+      </p:sp>
+      <p:sp>
+        <p:nvSpPr>
+          <p:cNvPr id="20" name="Rectangle 19"/>
           <p:cNvSpPr/>
           <p:nvPr/>
         </p:nvSpPr>
         <p:spPr>
           <a:xfrm>
-            <a:off x="4206240" y="1645920"/>
-            <a:ext cx="3474720" cy="2377440"/>
+            <a:off x="6217920" y="2834640"/>
+            <a:ext cx="5303520" cy="1097280"/>
           </a:xfrm>
           <a:prstGeom prst="rect">
             <a:avLst/>
@@ -16950,20 +17348,20 @@
       </p:sp>
       <p:sp>
         <p:nvSpPr>
-          <p:cNvPr id="11" name="Rectangle 10"/>
+          <p:cNvPr id="21" name="Rectangle 20"/>
           <p:cNvSpPr/>
           <p:nvPr/>
         </p:nvSpPr>
         <p:spPr>
           <a:xfrm>
-            <a:off x="4206240" y="1645920"/>
-            <a:ext cx="3474720" cy="54864"/>
+            <a:off x="6217920" y="2834640"/>
+            <a:ext cx="5303520" cy="54864"/>
           </a:xfrm>
           <a:prstGeom prst="rect">
             <a:avLst/>
           </a:prstGeom>
           <a:solidFill>
-            <a:srgbClr val="FF8C00"/>
+            <a:srgbClr val="0078D4"/>
           </a:solidFill>
           <a:ln>
             <a:noFill/>
@@ -16993,20 +17391,20 @@
       </p:sp>
       <p:sp>
         <p:nvSpPr>
-          <p:cNvPr id="12" name="Oval 11"/>
+          <p:cNvPr id="22" name="Oval 21"/>
           <p:cNvSpPr/>
           <p:nvPr/>
         </p:nvSpPr>
         <p:spPr>
           <a:xfrm>
-            <a:off x="4480560" y="1920240"/>
+            <a:off x="6492240" y="3108960"/>
             <a:ext cx="640080" cy="640080"/>
           </a:xfrm>
           <a:prstGeom prst="ellipse">
             <a:avLst/>
           </a:prstGeom>
           <a:solidFill>
-            <a:srgbClr val="FF8C00"/>
+            <a:srgbClr val="0078D4"/>
           </a:solidFill>
           <a:ln>
             <a:noFill/>
@@ -17038,21 +17436,21 @@
               </a:defRPr>
             </a:pPr>
             <a:r>
-              <a:t>🔧</a:t>
-            </a:r>
-          </a:p>
-        </p:txBody>
-      </p:sp>
-      <p:sp>
-        <p:nvSpPr>
-          <p:cNvPr id="13" name="TextBox 12"/>
+              <a:t>📋</a:t>
+            </a:r>
+          </a:p>
+        </p:txBody>
+      </p:sp>
+      <p:sp>
+        <p:nvSpPr>
+          <p:cNvPr id="23" name="TextBox 22"/>
           <p:cNvSpPr txBox="1"/>
           <p:nvPr/>
         </p:nvSpPr>
         <p:spPr>
           <a:xfrm>
-            <a:off x="4389120" y="2697480"/>
-            <a:ext cx="3108960" cy="365760"/>
+            <a:off x="6400800" y="3886200"/>
+            <a:ext cx="4937760" cy="365760"/>
           </a:xfrm>
           <a:prstGeom prst="rect">
             <a:avLst/>
@@ -17074,21 +17472,21 @@
               </a:defRPr>
             </a:pPr>
             <a:r>
-              <a:t>Tool Caller</a:t>
-            </a:r>
-          </a:p>
-        </p:txBody>
-      </p:sp>
-      <p:sp>
-        <p:nvSpPr>
-          <p:cNvPr id="14" name="TextBox 13"/>
+              <a:t>Instruction Adherence</a:t>
+            </a:r>
+          </a:p>
+        </p:txBody>
+      </p:sp>
+      <p:sp>
+        <p:nvSpPr>
+          <p:cNvPr id="24" name="TextBox 23"/>
           <p:cNvSpPr txBox="1"/>
           <p:nvPr/>
         </p:nvSpPr>
         <p:spPr>
           <a:xfrm>
-            <a:off x="4389120" y="3063240"/>
-            <a:ext cx="3108960" cy="731520"/>
+            <a:off x="6400800" y="4251960"/>
+            <a:ext cx="4937760" cy="-548640"/>
           </a:xfrm>
           <a:prstGeom prst="rect">
             <a:avLst/>
@@ -17110,42 +17508,29 @@
               </a:defRPr>
             </a:pPr>
             <a:r>
-              <a:t>Are function calls valid and</a:t>
+              <a:t>Does the model follow system/developer instructions</a:t>
             </a:r>
             <a:br/>
             <a:r>
-              <a:t>parameters correct?</a:t>
+              <a:t>the same way? Reasoning models (GPT-5+) may</a:t>
             </a:r>
             <a:br/>
-            <a:br/>
-            <a:r>
-              <a:t>• Function-call accuracy (name match)</a:t>
-            </a:r>
-            <a:br/>
-            <a:r>
-              <a:t>• Parameter extraction fidelity</a:t>
-            </a:r>
-            <a:br/>
-            <a:r>
-              <a:t>• Schema compliance checks</a:t>
-            </a:r>
-            <a:br/>
-            <a:r>
-              <a:t>• Deterministic — no LLM judge needed</a:t>
-            </a:r>
-          </a:p>
-        </p:txBody>
-      </p:sp>
-      <p:sp>
-        <p:nvSpPr>
-          <p:cNvPr id="15" name="Rectangle 14"/>
+            <a:r>
+              <a:t>interpret instructions more literally or broadly.</a:t>
+            </a:r>
+          </a:p>
+        </p:txBody>
+      </p:sp>
+      <p:sp>
+        <p:nvSpPr>
+          <p:cNvPr id="25" name="Rectangle 24"/>
           <p:cNvSpPr/>
           <p:nvPr/>
         </p:nvSpPr>
         <p:spPr>
           <a:xfrm>
-            <a:off x="8046720" y="1645920"/>
-            <a:ext cx="3474720" cy="2377440"/>
+            <a:off x="6217920" y="4114800"/>
+            <a:ext cx="5303520" cy="1097280"/>
           </a:xfrm>
           <a:prstGeom prst="rect">
             <a:avLst/>
@@ -17181,20 +17566,20 @@
       </p:sp>
       <p:sp>
         <p:nvSpPr>
-          <p:cNvPr id="16" name="Rectangle 15"/>
+          <p:cNvPr id="26" name="Rectangle 25"/>
           <p:cNvSpPr/>
           <p:nvPr/>
         </p:nvSpPr>
         <p:spPr>
           <a:xfrm>
-            <a:off x="8046720" y="1645920"/>
-            <a:ext cx="3474720" cy="54864"/>
+            <a:off x="6217920" y="4114800"/>
+            <a:ext cx="5303520" cy="54864"/>
           </a:xfrm>
           <a:prstGeom prst="rect">
             <a:avLst/>
           </a:prstGeom>
           <a:solidFill>
-            <a:srgbClr val="0078D4"/>
+            <a:srgbClr val="881E88"/>
           </a:solidFill>
           <a:ln>
             <a:noFill/>
@@ -17224,20 +17609,20 @@
       </p:sp>
       <p:sp>
         <p:nvSpPr>
-          <p:cNvPr id="17" name="Oval 16"/>
+          <p:cNvPr id="27" name="Oval 26"/>
           <p:cNvSpPr/>
           <p:nvPr/>
         </p:nvSpPr>
         <p:spPr>
           <a:xfrm>
-            <a:off x="8321040" y="1920240"/>
+            <a:off x="6492240" y="4389120"/>
             <a:ext cx="640080" cy="640080"/>
           </a:xfrm>
           <a:prstGeom prst="ellipse">
             <a:avLst/>
           </a:prstGeom>
           <a:solidFill>
-            <a:srgbClr val="0078D4"/>
+            <a:srgbClr val="881E88"/>
           </a:solidFill>
           <a:ln>
             <a:noFill/>
@@ -17269,21 +17654,21 @@
               </a:defRPr>
             </a:pPr>
             <a:r>
-              <a:t>📝</a:t>
-            </a:r>
-          </a:p>
-        </p:txBody>
-      </p:sp>
-      <p:sp>
-        <p:nvSpPr>
-          <p:cNvPr id="18" name="TextBox 17"/>
+              <a:t>📐</a:t>
+            </a:r>
+          </a:p>
+        </p:txBody>
+      </p:sp>
+      <p:sp>
+        <p:nvSpPr>
+          <p:cNvPr id="28" name="TextBox 27"/>
           <p:cNvSpPr txBox="1"/>
           <p:nvPr/>
         </p:nvSpPr>
         <p:spPr>
           <a:xfrm>
-            <a:off x="8229600" y="2697480"/>
-            <a:ext cx="3108960" cy="365760"/>
+            <a:off x="6400800" y="5166360"/>
+            <a:ext cx="4937760" cy="365760"/>
           </a:xfrm>
           <a:prstGeom prst="rect">
             <a:avLst/>
@@ -17305,21 +17690,21 @@
               </a:defRPr>
             </a:pPr>
             <a:r>
-              <a:t>Summarizer (lowest risk)</a:t>
-            </a:r>
-          </a:p>
-        </p:txBody>
-      </p:sp>
-      <p:sp>
-        <p:nvSpPr>
-          <p:cNvPr id="19" name="TextBox 18"/>
+              <a:t>Structured Output Stability</a:t>
+            </a:r>
+          </a:p>
+        </p:txBody>
+      </p:sp>
+      <p:sp>
+        <p:nvSpPr>
+          <p:cNvPr id="29" name="TextBox 28"/>
           <p:cNvSpPr txBox="1"/>
           <p:nvPr/>
         </p:nvSpPr>
         <p:spPr>
           <a:xfrm>
-            <a:off x="8229600" y="3063240"/>
-            <a:ext cx="3108960" cy="731520"/>
+            <a:off x="6400800" y="5532120"/>
+            <a:ext cx="4937760" cy="-548640"/>
           </a:xfrm>
           <a:prstGeom prst="rect">
             <a:avLst/>
@@ -17341,48 +17726,35 @@
               </a:defRPr>
             </a:pPr>
             <a:r>
-              <a:t>Is the final response coherent</a:t>
+              <a:t>Are function call schemas, JSON outputs, and</a:t>
             </a:r>
             <a:br/>
             <a:r>
-              <a:t>and complete?</a:t>
+              <a:t>parameter types still valid? Test schema</a:t>
             </a:r>
             <a:br/>
-            <a:br/>
-            <a:r>
-              <a:t>• Groundedness, Relevance (LLM judge)</a:t>
-            </a:r>
-            <a:br/>
-            <a:r>
-              <a:t>• Same scoring rubric as RAG</a:t>
-            </a:r>
-            <a:br/>
-            <a:r>
-              <a:t>• Correctness vs expected answer</a:t>
-            </a:r>
-            <a:br/>
-            <a:r>
-              <a:t>• Usually the last to migrate</a:t>
-            </a:r>
-          </a:p>
-        </p:txBody>
-      </p:sp>
-      <p:sp>
-        <p:nvSpPr>
-          <p:cNvPr id="20" name="Rectangle 19"/>
+            <a:r>
+              <a:t>compliance — different models parse differently.</a:t>
+            </a:r>
+          </a:p>
+        </p:txBody>
+      </p:sp>
+      <p:sp>
+        <p:nvSpPr>
+          <p:cNvPr id="30" name="Rectangle 29"/>
           <p:cNvSpPr/>
           <p:nvPr/>
         </p:nvSpPr>
         <p:spPr>
           <a:xfrm>
-            <a:off x="365760" y="4297680"/>
-            <a:ext cx="11155680" cy="2286000"/>
+            <a:off x="457200" y="5486400"/>
+            <a:ext cx="11155680" cy="1005840"/>
           </a:xfrm>
           <a:prstGeom prst="rect">
             <a:avLst/>
           </a:prstGeom>
           <a:solidFill>
-            <a:srgbClr val="F2F2F2"/>
+            <a:srgbClr val="002B5C"/>
           </a:solidFill>
           <a:ln>
             <a:noFill/>
@@ -17412,14 +17784,14 @@
       </p:sp>
       <p:sp>
         <p:nvSpPr>
-          <p:cNvPr id="21" name="TextBox 20"/>
+          <p:cNvPr id="31" name="TextBox 30"/>
           <p:cNvSpPr txBox="1"/>
           <p:nvPr/>
         </p:nvSpPr>
         <p:spPr>
           <a:xfrm>
-            <a:off x="548640" y="4389120"/>
-            <a:ext cx="5303520" cy="365760"/>
+            <a:off x="640080" y="5577840"/>
+            <a:ext cx="10789920" cy="365760"/>
           </a:xfrm>
           <a:prstGeom prst="rect">
             <a:avLst/>
@@ -17433,29 +17805,29 @@
           <a:lstStyle/>
           <a:p>
             <a:pPr algn="l">
-              <a:defRPr sz="1600" b="1">
-                <a:solidFill>
-                  <a:srgbClr val="002B5C"/>
-                </a:solidFill>
-                <a:latin typeface="Segoe UI"/>
-              </a:defRPr>
-            </a:pPr>
-            <a:r>
-              <a:t>Key difference: Tool-Sequence Stability</a:t>
-            </a:r>
-          </a:p>
-        </p:txBody>
-      </p:sp>
-      <p:sp>
-        <p:nvSpPr>
-          <p:cNvPr id="22" name="TextBox 21"/>
+              <a:defRPr sz="1500" b="1">
+                <a:solidFill>
+                  <a:srgbClr val="50E6FF"/>
+                </a:solidFill>
+                <a:latin typeface="Segoe UI"/>
+              </a:defRPr>
+            </a:pPr>
+            <a:r>
+              <a:t>Same dual-layer methodology applies:</a:t>
+            </a:r>
+          </a:p>
+        </p:txBody>
+      </p:sp>
+      <p:sp>
+        <p:nvSpPr>
+          <p:cNvPr id="32" name="TextBox 31"/>
           <p:cNvSpPr txBox="1"/>
           <p:nvPr/>
         </p:nvSpPr>
         <p:spPr>
           <a:xfrm>
-            <a:off x="548640" y="4754880"/>
-            <a:ext cx="5303520" cy="1645920"/>
+            <a:off x="640080" y="5852160"/>
+            <a:ext cx="10789920" cy="457200"/>
           </a:xfrm>
           <a:prstGeom prst="rect">
             <a:avLst/>
@@ -17471,408 +17843,17 @@
             <a:pPr algn="l">
               <a:defRPr sz="1300" b="0">
                 <a:solidFill>
-                  <a:srgbClr val="606060"/>
-                </a:solidFill>
-                <a:latin typeface="Segoe UI"/>
-              </a:defRPr>
-            </a:pPr>
-            <a:r>
-              <a:t>A new model may choose DIFFERENT tools in a different order</a:t>
-            </a:r>
-            <a:br/>
-            <a:r>
-              <a:t>but reach the same correct result. Your evaluation must</a:t>
-            </a:r>
-            <a:br/>
-            <a:r>
-              <a:t>distinguish:</a:t>
-            </a:r>
-            <a:br/>
-            <a:r>
-              <a:t>• Different path, same result → acceptable variation</a:t>
-            </a:r>
-            <a:br/>
-            <a:r>
-              <a:t>• Different path, different result → investigate</a:t>
-            </a:r>
-            <a:br/>
-            <a:r>
-              <a:t>• Wrong tools chosen → regression</a:t>
-            </a:r>
-            <a:br/>
-            <a:br/>
-            <a:r>
-              <a:t>Golden datasets should capture expected tool sequences AND</a:t>
-            </a:r>
-            <a:br/>
-            <a:r>
-              <a:t>acceptable alternatives.</a:t>
-            </a:r>
-          </a:p>
-        </p:txBody>
-      </p:sp>
-      <p:sp>
-        <p:nvSpPr>
-          <p:cNvPr id="23" name="TextBox 22"/>
-          <p:cNvSpPr txBox="1"/>
-          <p:nvPr/>
-        </p:nvSpPr>
-        <p:spPr>
-          <a:xfrm>
-            <a:off x="6217920" y="4389120"/>
-            <a:ext cx="5303520" cy="365760"/>
-          </a:xfrm>
-          <a:prstGeom prst="rect">
-            <a:avLst/>
-          </a:prstGeom>
-          <a:noFill/>
-        </p:spPr>
-        <p:txBody>
-          <a:bodyPr wrap="square">
-            <a:spAutoFit/>
-          </a:bodyPr>
-          <a:lstStyle/>
-          <a:p>
-            <a:pPr algn="l">
-              <a:defRPr sz="1600" b="1">
-                <a:solidFill>
-                  <a:srgbClr val="002B5C"/>
-                </a:solidFill>
-                <a:latin typeface="Segoe UI"/>
-              </a:defRPr>
-            </a:pPr>
-            <a:r>
-              <a:t>Agentic Golden Dataset Format</a:t>
-            </a:r>
-          </a:p>
-        </p:txBody>
-      </p:sp>
-      <p:graphicFrame>
-        <p:nvGraphicFramePr>
-          <p:cNvPr id="24" name="Table 23"/>
-          <p:cNvGraphicFramePr>
-            <a:graphicFrameLocks noGrp="1"/>
-          </p:cNvGraphicFramePr>
-          <p:nvPr/>
-        </p:nvGraphicFramePr>
-        <p:xfrm>
-          <a:off x="6217920" y="4754880"/>
-          <a:ext cx="5303520" cy="1645920"/>
-        </p:xfrm>
-        <a:graphic>
-          <a:graphicData uri="http://schemas.openxmlformats.org/drawingml/2006/table">
-            <a:tbl>
-              <a:tblPr firstRow="1" bandRow="1">
-                <a:tableStyleId>{5C22544A-7EE6-4342-B048-85BDC9FD1C3A}</a:tableStyleId>
-              </a:tblPr>
-              <a:tblGrid>
-                <a:gridCol w="2651760"/>
-                <a:gridCol w="2651760"/>
-              </a:tblGrid>
-              <a:tr h="274320">
-                <a:tc>
-                  <a:txBody>
-                    <a:bodyPr/>
-                    <a:lstStyle/>
-                    <a:p>
-                      <a:pPr algn="ctr">
-                        <a:defRPr sz="1300" b="1">
-                          <a:solidFill>
-                            <a:srgbClr val="FFFFFF"/>
-                          </a:solidFill>
-                          <a:latin typeface="Segoe UI"/>
-                        </a:defRPr>
-                      </a:pPr>
-                      <a:r>
-                        <a:t>Field</a:t>
-                      </a:r>
-                    </a:p>
-                  </a:txBody>
-                  <a:tcPr>
-                    <a:solidFill>
-                      <a:srgbClr val="107C10"/>
-                    </a:solidFill>
-                  </a:tcPr>
-                </a:tc>
-                <a:tc>
-                  <a:txBody>
-                    <a:bodyPr/>
-                    <a:lstStyle/>
-                    <a:p>
-                      <a:pPr algn="ctr">
-                        <a:defRPr sz="1300" b="1">
-                          <a:solidFill>
-                            <a:srgbClr val="FFFFFF"/>
-                          </a:solidFill>
-                          <a:latin typeface="Segoe UI"/>
-                        </a:defRPr>
-                      </a:pPr>
-                      <a:r>
-                        <a:t>Example</a:t>
-                      </a:r>
-                    </a:p>
-                  </a:txBody>
-                  <a:tcPr>
-                    <a:solidFill>
-                      <a:srgbClr val="107C10"/>
-                    </a:solidFill>
-                  </a:tcPr>
-                </a:tc>
-              </a:tr>
-              <a:tr h="274320">
-                <a:tc>
-                  <a:txBody>
-                    <a:bodyPr/>
-                    <a:lstStyle/>
-                    <a:p>
-                      <a:pPr>
-                        <a:defRPr sz="1200">
-                          <a:solidFill>
-                            <a:srgbClr val="111111"/>
-                          </a:solidFill>
-                          <a:latin typeface="Segoe UI"/>
-                        </a:defRPr>
-                      </a:pPr>
-                      <a:r>
-                        <a:t>user_request</a:t>
-                      </a:r>
-                    </a:p>
-                  </a:txBody>
-                  <a:tcPr>
-                    <a:solidFill>
-                      <a:srgbClr val="F2F2F2"/>
-                    </a:solidFill>
-                  </a:tcPr>
-                </a:tc>
-                <a:tc>
-                  <a:txBody>
-                    <a:bodyPr/>
-                    <a:lstStyle/>
-                    <a:p>
-                      <a:pPr>
-                        <a:defRPr sz="1200">
-                          <a:solidFill>
-                            <a:srgbClr val="111111"/>
-                          </a:solidFill>
-                          <a:latin typeface="Segoe UI"/>
-                        </a:defRPr>
-                      </a:pPr>
-                      <a:r>
-                        <a:t>"Book a meeting with John next Tuesday at 2pm"</a:t>
-                      </a:r>
-                    </a:p>
-                  </a:txBody>
-                  <a:tcPr>
-                    <a:solidFill>
-                      <a:srgbClr val="F2F2F2"/>
-                    </a:solidFill>
-                  </a:tcPr>
-                </a:tc>
-              </a:tr>
-              <a:tr h="274320">
-                <a:tc>
-                  <a:txBody>
-                    <a:bodyPr/>
-                    <a:lstStyle/>
-                    <a:p>
-                      <a:pPr>
-                        <a:defRPr sz="1200">
-                          <a:solidFill>
-                            <a:srgbClr val="111111"/>
-                          </a:solidFill>
-                          <a:latin typeface="Segoe UI"/>
-                        </a:defRPr>
-                      </a:pPr>
-                      <a:r>
-                        <a:t>expected_tools</a:t>
-                      </a:r>
-                    </a:p>
-                  </a:txBody>
-                  <a:tcPr>
-                    <a:solidFill>
-                      <a:srgbClr val="FFFFFF"/>
-                    </a:solidFill>
-                  </a:tcPr>
-                </a:tc>
-                <a:tc>
-                  <a:txBody>
-                    <a:bodyPr/>
-                    <a:lstStyle/>
-                    <a:p>
-                      <a:pPr>
-                        <a:defRPr sz="1200">
-                          <a:solidFill>
-                            <a:srgbClr val="111111"/>
-                          </a:solidFill>
-                          <a:latin typeface="Segoe UI"/>
-                        </a:defRPr>
-                      </a:pPr>
-                      <a:r>
-                        <a:t>["calendar.check_availability", "calendar.create_event"]</a:t>
-                      </a:r>
-                    </a:p>
-                  </a:txBody>
-                  <a:tcPr>
-                    <a:solidFill>
-                      <a:srgbClr val="FFFFFF"/>
-                    </a:solidFill>
-                  </a:tcPr>
-                </a:tc>
-              </a:tr>
-              <a:tr h="274320">
-                <a:tc>
-                  <a:txBody>
-                    <a:bodyPr/>
-                    <a:lstStyle/>
-                    <a:p>
-                      <a:pPr>
-                        <a:defRPr sz="1200">
-                          <a:solidFill>
-                            <a:srgbClr val="111111"/>
-                          </a:solidFill>
-                          <a:latin typeface="Segoe UI"/>
-                        </a:defRPr>
-                      </a:pPr>
-                      <a:r>
-                        <a:t>expected_params</a:t>
-                      </a:r>
-                    </a:p>
-                  </a:txBody>
-                  <a:tcPr>
-                    <a:solidFill>
-                      <a:srgbClr val="F2F2F2"/>
-                    </a:solidFill>
-                  </a:tcPr>
-                </a:tc>
-                <a:tc>
-                  <a:txBody>
-                    <a:bodyPr/>
-                    <a:lstStyle/>
-                    <a:p>
-                      <a:pPr>
-                        <a:defRPr sz="1200">
-                          <a:solidFill>
-                            <a:srgbClr val="111111"/>
-                          </a:solidFill>
-                          <a:latin typeface="Segoe UI"/>
-                        </a:defRPr>
-                      </a:pPr>
-                      <a:r>
-                        <a:t>{"attendee": "John", "day": "Tuesday", "time": "14:00"}</a:t>
-                      </a:r>
-                    </a:p>
-                  </a:txBody>
-                  <a:tcPr>
-                    <a:solidFill>
-                      <a:srgbClr val="F2F2F2"/>
-                    </a:solidFill>
-                  </a:tcPr>
-                </a:tc>
-              </a:tr>
-              <a:tr h="274320">
-                <a:tc>
-                  <a:txBody>
-                    <a:bodyPr/>
-                    <a:lstStyle/>
-                    <a:p>
-                      <a:pPr>
-                        <a:defRPr sz="1200">
-                          <a:solidFill>
-                            <a:srgbClr val="111111"/>
-                          </a:solidFill>
-                          <a:latin typeface="Segoe UI"/>
-                        </a:defRPr>
-                      </a:pPr>
-                      <a:r>
-                        <a:t>expected_answer</a:t>
-                      </a:r>
-                    </a:p>
-                  </a:txBody>
-                  <a:tcPr>
-                    <a:solidFill>
-                      <a:srgbClr val="FFFFFF"/>
-                    </a:solidFill>
-                  </a:tcPr>
-                </a:tc>
-                <a:tc>
-                  <a:txBody>
-                    <a:bodyPr/>
-                    <a:lstStyle/>
-                    <a:p>
-                      <a:pPr>
-                        <a:defRPr sz="1200">
-                          <a:solidFill>
-                            <a:srgbClr val="111111"/>
-                          </a:solidFill>
-                          <a:latin typeface="Segoe UI"/>
-                        </a:defRPr>
-                      </a:pPr>
-                      <a:r>
-                        <a:t>"Meeting booked for Tue at 2:00 PM with John"</a:t>
-                      </a:r>
-                    </a:p>
-                  </a:txBody>
-                  <a:tcPr>
-                    <a:solidFill>
-                      <a:srgbClr val="FFFFFF"/>
-                    </a:solidFill>
-                  </a:tcPr>
-                </a:tc>
-              </a:tr>
-              <a:tr h="274320">
-                <a:tc>
-                  <a:txBody>
-                    <a:bodyPr/>
-                    <a:lstStyle/>
-                    <a:p>
-                      <a:pPr>
-                        <a:defRPr sz="1200">
-                          <a:solidFill>
-                            <a:srgbClr val="111111"/>
-                          </a:solidFill>
-                          <a:latin typeface="Segoe UI"/>
-                        </a:defRPr>
-                      </a:pPr>
-                      <a:r>
-                        <a:t>alt_tool_paths</a:t>
-                      </a:r>
-                    </a:p>
-                  </a:txBody>
-                  <a:tcPr>
-                    <a:solidFill>
-                      <a:srgbClr val="F2F2F2"/>
-                    </a:solidFill>
-                  </a:tcPr>
-                </a:tc>
-                <a:tc>
-                  <a:txBody>
-                    <a:bodyPr/>
-                    <a:lstStyle/>
-                    <a:p>
-                      <a:pPr>
-                        <a:defRPr sz="1200">
-                          <a:solidFill>
-                            <a:srgbClr val="111111"/>
-                          </a:solidFill>
-                          <a:latin typeface="Segoe UI"/>
-                        </a:defRPr>
-                      </a:pPr>
-                      <a:r>
-                        <a:t>[["calendar.search", "calendar.create_event"]]</a:t>
-                      </a:r>
-                    </a:p>
-                  </a:txBody>
-                  <a:tcPr>
-                    <a:solidFill>
-                      <a:srgbClr val="F2F2F2"/>
-                    </a:solidFill>
-                  </a:tcPr>
-                </a:tc>
-              </a:tr>
-            </a:tbl>
-          </a:graphicData>
-        </a:graphic>
-      </p:graphicFrame>
+                  <a:srgbClr val="FFFFFF"/>
+                </a:solidFill>
+                <a:latin typeface="Segoe UI"/>
+              </a:defRPr>
+            </a:pPr>
+            <a:r>
+              <a:t>E2E: run agent with golden requests → compare final answers before/after    •    Task-level: check tool selections, parameter accuracy, response quality independently</a:t>
+            </a:r>
+          </a:p>
+        </p:txBody>
+      </p:sp>
     </p:spTree>
   </p:cSld>
   <p:clrMapOvr>

</xml_diff>

<commit_message>
docs: add chat UI demo reference to presentation
Co-authored-by: Copilot <223556219+Copilot@users.noreply.github.com>
</commit_message>
<xml_diff>
--- a/docs/azure-openai-model-migration-approach.pptx
+++ b/docs/azure-openai-model-migration-approach.pptx
@@ -4038,6 +4038,18 @@
             </a:pPr>
             <a:r>
               <a:t>Proven: We ran gpt-4o → gpt-4.1 → gpt-5.4-mini with the SAME script, SAME dataset. All passing.</a:t>
+            </a:r>
+          </a:p>
+          <a:p>
+            <a:pPr>
+              <a:defRPr sz="1200" b="1">
+                <a:solidFill>
+                  <a:srgbClr val="0078D4"/>
+                </a:solidFill>
+              </a:defRPr>
+            </a:pPr>
+            <a:r>
+              <a:t>💬 Interactive demo: chainlit run app.py — swap models live via Settings panel.</a:t>
             </a:r>
           </a:p>
         </p:txBody>

</xml_diff>